<commit_message>
avance de informe y diagramas
</commit_message>
<xml_diff>
--- a/docs/entregables/MEDIFAST_APF3_Sustentacion.pptx
+++ b/docs/entregables/MEDIFAST_APF3_Sustentacion.pptx
@@ -315,13 +315,13 @@
                   <c:v>97</c:v>
                 </c:pt>
                 <c:pt idx="2">
-                  <c:v>79</c:v>
+                  <c:v>77</c:v>
                 </c:pt>
                 <c:pt idx="3">
-                  <c:v>74</c:v>
+                  <c:v>58</c:v>
                 </c:pt>
                 <c:pt idx="4">
-                  <c:v>70</c:v>
+                  <c:v>73</c:v>
                 </c:pt>
               </c:numCache>
             </c:numRef>
@@ -688,8 +688,8 @@
             <a:r>
               <a:rPr lang="en-US" dirty="0"/>
               <a:t>Expone: Jennifer.
-Tenemos 70 pruebas automatizadas en 12 clases, con JUnit 5 y Mockito, y todas pasan con ./mvnw test. Cubren las reglas de reserva —por ejemplo, que a un paciente nuevo solo se le ofrezcan inicios con dos bloques consecutivos libres, o que se rechacen fechas fuera de la ventana de 30 días—, el registro, la seguridad (bcrypt, bloqueo por intentos, redirección por rol) y los controladores.
-JaCoCo reporta 70 % de cobertura total y 79 % en la capa de servicios, por encima de la meta del 60 % que nos pusimos. Le paso la palabra a Jack, que mostrará las interfaces.</a:t>
+Tenemos 91 pruebas automatizadas en 17 clases, con JUnit 5 y Mockito, y todas pasan con ./mvnw test. Cubren las reglas de reserva —por ejemplo, que a un paciente nuevo solo se le ofrezcan inicios con dos bloques consecutivos libres, o que se rechacen fechas fuera de la ventana de 30 días—, el registro, la seguridad (bcrypt, bloqueo por intentos, redirección por rol), la generación de horarios, los reportes con su exportación a Excel y los controladores.
+JaCoCo reporta 73 % de cobertura total y 77 % en la capa de servicios, por encima de la meta del 60 % que nos pusimos. Le paso la palabra a Jack, que mostrará las interfaces.</a:t>
             </a:r>
           </a:p>
         </p:txBody>
@@ -867,7 +867,7 @@
               <a:rPr lang="en-US" dirty="0"/>
               <a:t>Expone: Jack.
 El flujo del paciente tiene cuatro pasos. En P2 elige fecha y hora: el sistema ya detectó si es paciente nuevo o control, muestra solo los bloques libres y, al continuar, aparta el horario 15 minutos. En P3 ve el monto, un QR de ejemplo con la leyenda de simulación y un contador; adjunta su constancia. En P4 obtiene la confirmación con descarga en PDF, y en P5 consulta su historial.
-P2 ya está implementada en Spring Boot y conectada a la base de datos; P3, P4 y P5 están diseñadas y son las siguientes en implementarse.</a:t>
+P2, P3 y P4 ya están implementadas en Spring Boot y conectadas a la base de datos; a la confirmación le falta la descarga en PDF. P5 está diseñada y es la siguiente en implementarse.</a:t>
             </a:r>
           </a:p>
         </p:txBody>
@@ -956,7 +956,7 @@
               <a:rPr lang="en-US" dirty="0"/>
               <a:t>Expone: Jack.
 El médico entra directamente a su agenda (P7), con vista por día o semana, filtros por estado e indicadores. Desde ahí abre el detalle de una cita (P8): ve la constancia de pago y la valida o rechaza; rechazar o cancelar exige una observación, y solo puede marcar atendida si el pago está validado.
-Tiene dos reportes. El de pagos (P10) ya está implementado: filtra por período, muestra cantidad, total y ticket promedio, y exporta a Excel con Apache POI. El de citas (P9), la agenda y el detalle están diseñados y en desarrollo.</a:t>
+Tiene dos reportes, y ambos ya están implementados. El de citas (P9) filtra por día, semana y estado y muestra total, atendidas, canceladas y no asistieron. El de pagos (P10) filtra por período y muestra cantidad, total y ticket promedio. Los dos exportan a Excel con Apache POI. La agenda y el detalle de cita están diseñados y en desarrollo.</a:t>
             </a:r>
           </a:p>
         </p:txBody>
@@ -1044,7 +1044,7 @@
             <a:r>
               <a:rPr lang="en-US" dirty="0"/>
               <a:t>Expone: Jack.
-Con transparencia, este es el estado frente al alcance comprometido. Las 11 pantallas tienen su diseño aprobado. En código, ya funcionan con su lógica y base de datos el login, el registro, la reserva de citas y el reporte de pagos con exportación a Excel, además de las páginas de error 403 y 404. Las siete restantes están en implementación para completar el 100 % del alcance.
+Con transparencia, este es el estado frente al alcance comprometido. Las 11 pantallas tienen su diseño aprobado. En código, ya funcionan con su lógica y base de datos siete: el login, el registro, la reserva de citas, el pago simulado, la confirmación y los dos reportes con exportación a Excel, además de las páginas de error 403 y 404. Las cuatro restantes —mis citas, mi perfil, la agenda y el detalle de cita— están en implementación para completar el 100 % del alcance.
 Lo que sí garantizamos es la coherencia: el README es la referencia única, y el código, los scripts SQL, los diagramas y los diseños usan los mismos identificadores de pantallas, requerimientos y reglas.</a:t>
             </a:r>
           </a:p>
@@ -1133,8 +1133,8 @@
             <a:r>
               <a:rPr lang="en-US" dirty="0"/>
               <a:t>Expone: Jack (con apoyo de todo el equipo en la demo).
-Ahora lo vemos funcionando en localhost. Primero el flujo del paciente: registro, inicio de sesión y reserva de una cita, donde el horario queda apartado 15 minutos. Luego el médico: inicio de sesión, reporte de pagos y exportación a Excel. Por último, la seguridad: un paciente que intenta entrar a una ruta de médico recibe 403, y tras cinco intentos fallidos la cuenta se bloquea.
-Para la entrega final implementaremos las pantallas P3 a P9 sobre los diseños ya aprobados, incorporaremos Commons IO y OpenPDF, completaremos las pruebas de las 14 reglas de negocio y validaremos el sistema con el Dr. Barrantes. Muchas gracias; quedamos atentos a sus preguntas.</a:t>
+Ahora lo vemos funcionando en localhost. Primero el flujo del paciente: registro, inicio de sesión, reserva de una cita —el horario queda apartado 15 minutos—, pago simulado con Yape adjuntando la constancia y la confirmación. Luego el médico: inicio de sesión, reportes de citas y de pagos, y exportación a Excel. Por último, la seguridad: un paciente que intenta entrar a una ruta de médico recibe 403, y tras cinco intentos fallidos la cuenta se bloquea.
+Para la entrega final implementaremos las pantallas P5 a P8 sobre los diseños ya aprobados, incorporaremos Commons IO y OpenPDF, completaremos las pruebas de las 14 reglas de negocio y validaremos el sistema con el Dr. Barrantes. Muchas gracias; quedamos atentos a sus preguntas.</a:t>
             </a:r>
           </a:p>
         </p:txBody>
@@ -1402,7 +1402,7 @@
               <a:rPr lang="en-US" dirty="0"/>
               <a:t>Expone: Manuel.
 Trabajamos con Extreme Programming, con entregas iterativas e incrementales. En el APF1 analizamos el negocio y entrevistamos al Dr. Barrantes; en el APF2 definimos requerimientos, el modelo lógico, la arquitectura y el prototipo.
-En este APF3 pasamos a la construcción. Lo organizamos en iteraciones cortas: primero la base (esquema MySQL, entidades y DAO), luego autenticación y registro, la reserva de citas, el reporte de pagos con exportación a Excel y, en paralelo, el diseño de las pantallas restantes. Cada iteración vivió en su propia rama y entró a main mediante pull request. Para la entrega final queda completar el alcance y validar con el cliente.</a:t>
+En este APF3 pasamos a la construcción. Lo organizamos en iteraciones cortas: primero la base (esquema MySQL, entidades y DAO), luego autenticación y registro, la reserva de citas, el pago simulado con su confirmación, los reportes de citas y pagos con exportación a Excel, la generación automática de horarios y, en paralelo, el diseño de las pantallas restantes. Cada iteración vivió en su propia rama y entró a main mediante pull request. Para la entrega final queda completar el alcance y validar con el cliente.</a:t>
             </a:r>
           </a:p>
         </p:txBody>
@@ -1580,7 +1580,7 @@
               <a:rPr lang="en-US" dirty="0"/>
               <a:t>Expone: Manuel.
 La rúbrica pide al menos tres de estos principios; aplicamos los cuatro.
-MVC: modelo con entidades y DTO, vistas Thymeleaf y controladores delgados. DAO: cada tabla tiene su interfaz que extiende JpaRepository, con consultas propias para disponibilidad y reportes. SOLID: por ejemplo, ExportadorReporte es una interfaz; el controlador de reportes depende de ella y no de Apache POI, así que agregar un exportador a PDF no obliga a tocar el servicio —principios abierto/cerrado e inversión de dependencias—. TDD: 70 pruebas con JUnit 5 y Mockito, que veremos más adelante.</a:t>
+MVC: modelo con entidades y DTO, vistas Thymeleaf y controladores delgados. DAO: cada tabla tiene su interfaz que extiende JpaRepository, con consultas propias para disponibilidad y reportes. SOLID: por ejemplo, ExportadorReporte es una interfaz; el controlador de reportes depende de ella y no de Apache POI, así que agregar un exportador a PDF no obliga a tocar el servicio —principios abierto/cerrado e inversión de dependencias—. TDD: 91 pruebas con JUnit 5 y Mockito, que veremos más adelante.</a:t>
             </a:r>
           </a:p>
         </p:txBody>
@@ -1668,7 +1668,7 @@
             <a:r>
               <a:rPr lang="en-US" dirty="0"/>
               <a:t>Expone: Manuel.
-Todo el proyecto está en GitHub: 79 commits en main y 21 pull requests, de los cuales 17 ya están integrados. El flujo es siempre el mismo: una rama feature por funcionalidad o pantalla, commits pequeños, un pull request que revisa el equipo y la integración a main.
+Todo el proyecto está en GitHub: 98 commits en main y 24 pull requests, de los cuales 23 ya están integrados. El flujo es siempre el mismo: una rama feature por funcionalidad o pantalla, commits pequeños, un pull request que revisa el equipo y la integración a main.
 No solo versionamos código: también los scripts SQL, los diagramas en Mermaid, la bitácora de diseño con cada prompt y captura, y los entregables anteriores. El README es la fuente única de verdad: si un documento lo contradice, se corrige el documento. Ahora Jennifer presentará seguridad, librerías y pruebas.</a:t>
             </a:r>
           </a:p>
@@ -1846,8 +1846,8 @@
             <a:r>
               <a:rPr lang="en-US" dirty="0"/>
               <a:t>Expone: Jennifer.
-No basta con declarar las librerías en el pom.xml: cada una debe tener un uso real. Google Guava se usa para la caché de intentos de login. Apache Commons Lang3, con StringUtils, normaliza nombres y documentos en el registro, el enmascarador y la auditoría. Apache POI genera el Excel del reporte de pagos. Logback está configurado con consola, archivo rotativo y un log de auditoría separado, y enmascara los datos sensibles.
-Con honestidad: Commons IO y OpenPDF ya están en el pom.xml, pero su uso llega con la pantalla de pago (guardar la constancia) y la de confirmación (PDF), que están en desarrollo.</a:t>
+No basta con declarar las librerías en el pom.xml: cada una debe tener un uso real. Google Guava se usa para la caché de intentos de login. Apache Commons Lang3, con StringUtils, normaliza nombres y documentos en el registro, el enmascarador y la auditoría. Apache POI genera el Excel de los reportes de citas y de pagos. Logback está configurado con consola, archivo rotativo y un log de auditoría separado, y enmascara los datos sensibles.
+Con honestidad: Commons IO y OpenPDF ya están en el pom.xml, pero todavía no se usan. Las pantallas de pago y de confirmación ya funcionan: hoy la constancia se guarda con java.nio y un nombre UUID, y la descarga en PDF de la confirmación es lo siguiente que implementaremos.</a:t>
             </a:r>
           </a:p>
         </p:txBody>
@@ -3134,7 +3134,7 @@
                   <a:schemeClr val="tx1"/>
                 </a:solidFill>
               </a:rPr>
-              <a:t>70 pruebas automatizadas en verde</a:t>
+              <a:t>91 pruebas automatizadas en verde</a:t>
             </a:r>
             <a:endParaRPr lang="en-US" sz="3600" dirty="0"/>
           </a:p>
@@ -3211,7 +3211,7 @@
                   <a:schemeClr val="tx2"/>
                 </a:solidFill>
               </a:rPr>
-              <a:t>70</a:t>
+              <a:t>91</a:t>
             </a:r>
             <a:endParaRPr lang="en-US" sz="4400" dirty="0"/>
           </a:p>
@@ -3338,7 +3338,7 @@
                   <a:schemeClr val="tx2"/>
                 </a:solidFill>
               </a:rPr>
-              <a:t>70 %</a:t>
+              <a:t>73 %</a:t>
             </a:r>
             <a:endParaRPr lang="en-US" sz="4400" dirty="0"/>
           </a:p>
@@ -3465,7 +3465,7 @@
                   <a:schemeClr val="tx2"/>
                 </a:solidFill>
               </a:rPr>
-              <a:t>79 %</a:t>
+              <a:t>77 %</a:t>
             </a:r>
             <a:endParaRPr lang="en-US" sz="4400" dirty="0"/>
           </a:p>
@@ -7150,7 +7150,7 @@
             <a:avLst/>
           </a:prstGeom>
           <a:solidFill>
-            <a:srgbClr val="FEF3C7"/>
+            <a:srgbClr val="D1FAE5"/>
           </a:solidFill>
           <a:ln/>
         </p:spPr>
@@ -7164,10 +7164,10 @@
             <a:r>
               <a:rPr lang="en-US" sz="1000" b="1" dirty="0">
                 <a:solidFill>
-                  <a:srgbClr val="92400E"/>
-                </a:solidFill>
-              </a:rPr>
-              <a:t>Diseñada</a:t>
+                  <a:schemeClr val="tx2"/>
+                </a:solidFill>
+              </a:rPr>
+              <a:t>Implementada</a:t>
             </a:r>
             <a:endParaRPr lang="en-US" sz="1000" dirty="0"/>
           </a:p>
@@ -9562,11 +9562,11 @@
             </a:avLst>
           </a:prstGeom>
           <a:solidFill>
-            <a:schemeClr val="bg2"/>
+            <a:schemeClr val="tx2"/>
           </a:solidFill>
           <a:ln w="12700">
             <a:solidFill>
-              <a:srgbClr val="E2E8F0"/>
+              <a:schemeClr val="tx2"/>
             </a:solidFill>
             <a:prstDash val="solid"/>
           </a:ln>
@@ -9606,7 +9606,7 @@
             <a:r>
               <a:rPr lang="en-US" sz="2200" b="1" dirty="0">
                 <a:solidFill>
-                  <a:schemeClr val="tx1"/>
+                  <a:schemeClr val="bg1"/>
                 </a:solidFill>
               </a:rPr>
               <a:t>P3</a:t>
@@ -9620,7 +9620,7 @@
             <a:r>
               <a:rPr lang="en-US" sz="1100" dirty="0">
                 <a:solidFill>
-                  <a:schemeClr val="tx1"/>
+                  <a:schemeClr val="bg1"/>
                 </a:solidFill>
               </a:rPr>
               <a:t>Pago Yape</a:t>
@@ -9638,6 +9638,90 @@
         <p:spPr>
           <a:xfrm>
             <a:off x="5669280" y="1691640"/>
+            <a:ext cx="1143000" cy="1188720"/>
+          </a:xfrm>
+          <a:prstGeom prst="roundRect">
+            <a:avLst>
+              <a:gd name="adj" fmla="val 8000"/>
+            </a:avLst>
+          </a:prstGeom>
+          <a:solidFill>
+            <a:schemeClr val="tx2"/>
+          </a:solidFill>
+          <a:ln w="12700">
+            <a:solidFill>
+              <a:schemeClr val="tx2"/>
+            </a:solidFill>
+            <a:prstDash val="solid"/>
+          </a:ln>
+        </p:spPr>
+        <p:txBody>
+          <a:bodyPr/>
+          <a:lstStyle/>
+          <a:p>
+            <a:endParaRPr lang="es-PE"/>
+          </a:p>
+        </p:txBody>
+      </p:sp>
+      <p:sp>
+        <p:nvSpPr>
+          <p:cNvPr id="15" name="Text 13"/>
+          <p:cNvSpPr txBox="1"/>
+          <p:nvPr/>
+        </p:nvSpPr>
+        <p:spPr>
+          <a:xfrm>
+            <a:off x="5669280" y="1691640"/>
+            <a:ext cx="1143000" cy="1188720"/>
+          </a:xfrm>
+          <a:prstGeom prst="rect">
+            <a:avLst/>
+          </a:prstGeom>
+          <a:noFill/>
+          <a:ln/>
+        </p:spPr>
+        <p:txBody>
+          <a:bodyPr wrap="square" lIns="0" tIns="0" rIns="0" bIns="0" rtlCol="0" anchor="ctr"/>
+          <a:lstStyle/>
+          <a:p>
+            <a:pPr marL="0" indent="0" algn="ctr">
+              <a:buNone/>
+            </a:pPr>
+            <a:r>
+              <a:rPr lang="en-US" sz="2200" b="1" dirty="0">
+                <a:solidFill>
+                  <a:schemeClr val="bg1"/>
+                </a:solidFill>
+              </a:rPr>
+              <a:t>P4</a:t>
+            </a:r>
+            <a:endParaRPr lang="en-US" sz="2200" dirty="0"/>
+          </a:p>
+          <a:p>
+            <a:pPr marL="0" indent="0" algn="ctr">
+              <a:buNone/>
+            </a:pPr>
+            <a:r>
+              <a:rPr lang="en-US" sz="1100" dirty="0">
+                <a:solidFill>
+                  <a:schemeClr val="bg1"/>
+                </a:solidFill>
+              </a:rPr>
+              <a:t>Confirmación</a:t>
+            </a:r>
+            <a:endParaRPr lang="en-US" sz="2200" dirty="0"/>
+          </a:p>
+        </p:txBody>
+      </p:sp>
+      <p:sp>
+        <p:nvSpPr>
+          <p:cNvPr id="16" name="screen-P5"/>
+          <p:cNvSpPr/>
+          <p:nvPr/>
+        </p:nvSpPr>
+        <p:spPr>
+          <a:xfrm>
+            <a:off x="6949440" y="1691640"/>
             <a:ext cx="1143000" cy="1188720"/>
           </a:xfrm>
           <a:prstGeom prst="roundRect">
@@ -9665,13 +9749,13 @@
       </p:sp>
       <p:sp>
         <p:nvSpPr>
-          <p:cNvPr id="15" name="Text 13"/>
+          <p:cNvPr id="17" name="Text 15"/>
           <p:cNvSpPr txBox="1"/>
           <p:nvPr/>
         </p:nvSpPr>
         <p:spPr>
           <a:xfrm>
-            <a:off x="5669280" y="1691640"/>
+            <a:off x="6949440" y="1691640"/>
             <a:ext cx="1143000" cy="1188720"/>
           </a:xfrm>
           <a:prstGeom prst="rect">
@@ -9693,7 +9777,7 @@
                   <a:schemeClr val="tx1"/>
                 </a:solidFill>
               </a:rPr>
-              <a:t>P4</a:t>
+              <a:t>P5</a:t>
             </a:r>
             <a:endParaRPr lang="en-US" sz="2200" dirty="0"/>
           </a:p>
@@ -9707,7 +9791,7 @@
                   <a:schemeClr val="tx1"/>
                 </a:solidFill>
               </a:rPr>
-              <a:t>Confirmación</a:t>
+              <a:t>Mis citas</a:t>
             </a:r>
             <a:endParaRPr lang="en-US" sz="2200" dirty="0"/>
           </a:p>
@@ -9715,13 +9799,13 @@
       </p:sp>
       <p:sp>
         <p:nvSpPr>
-          <p:cNvPr id="16" name="screen-P5"/>
+          <p:cNvPr id="18" name="screen-P6"/>
           <p:cNvSpPr/>
           <p:nvPr/>
         </p:nvSpPr>
         <p:spPr>
           <a:xfrm>
-            <a:off x="6949440" y="1691640"/>
+            <a:off x="548640" y="3063240"/>
             <a:ext cx="1143000" cy="1188720"/>
           </a:xfrm>
           <a:prstGeom prst="roundRect">
@@ -9749,13 +9833,13 @@
       </p:sp>
       <p:sp>
         <p:nvSpPr>
-          <p:cNvPr id="17" name="Text 15"/>
+          <p:cNvPr id="19" name="Text 17"/>
           <p:cNvSpPr txBox="1"/>
           <p:nvPr/>
         </p:nvSpPr>
         <p:spPr>
           <a:xfrm>
-            <a:off x="6949440" y="1691640"/>
+            <a:off x="548640" y="3063240"/>
             <a:ext cx="1143000" cy="1188720"/>
           </a:xfrm>
           <a:prstGeom prst="rect">
@@ -9777,7 +9861,7 @@
                   <a:schemeClr val="tx1"/>
                 </a:solidFill>
               </a:rPr>
-              <a:t>P5</a:t>
+              <a:t>P6</a:t>
             </a:r>
             <a:endParaRPr lang="en-US" sz="2200" dirty="0"/>
           </a:p>
@@ -9791,7 +9875,7 @@
                   <a:schemeClr val="tx1"/>
                 </a:solidFill>
               </a:rPr>
-              <a:t>Mis citas</a:t>
+              <a:t>Mi perfil</a:t>
             </a:r>
             <a:endParaRPr lang="en-US" sz="2200" dirty="0"/>
           </a:p>
@@ -9799,13 +9883,13 @@
       </p:sp>
       <p:sp>
         <p:nvSpPr>
-          <p:cNvPr id="18" name="screen-P6"/>
+          <p:cNvPr id="20" name="screen-P7"/>
           <p:cNvSpPr/>
           <p:nvPr/>
         </p:nvSpPr>
         <p:spPr>
           <a:xfrm>
-            <a:off x="548640" y="3063240"/>
+            <a:off x="1828800" y="3063240"/>
             <a:ext cx="1143000" cy="1188720"/>
           </a:xfrm>
           <a:prstGeom prst="roundRect">
@@ -9833,13 +9917,13 @@
       </p:sp>
       <p:sp>
         <p:nvSpPr>
-          <p:cNvPr id="19" name="Text 17"/>
+          <p:cNvPr id="21" name="Text 19"/>
           <p:cNvSpPr txBox="1"/>
           <p:nvPr/>
         </p:nvSpPr>
         <p:spPr>
           <a:xfrm>
-            <a:off x="548640" y="3063240"/>
+            <a:off x="1828800" y="3063240"/>
             <a:ext cx="1143000" cy="1188720"/>
           </a:xfrm>
           <a:prstGeom prst="rect">
@@ -9861,7 +9945,7 @@
                   <a:schemeClr val="tx1"/>
                 </a:solidFill>
               </a:rPr>
-              <a:t>P6</a:t>
+              <a:t>P7</a:t>
             </a:r>
             <a:endParaRPr lang="en-US" sz="2200" dirty="0"/>
           </a:p>
@@ -9875,7 +9959,7 @@
                   <a:schemeClr val="tx1"/>
                 </a:solidFill>
               </a:rPr>
-              <a:t>Mi perfil</a:t>
+              <a:t>Agenda</a:t>
             </a:r>
             <a:endParaRPr lang="en-US" sz="2200" dirty="0"/>
           </a:p>
@@ -9883,13 +9967,13 @@
       </p:sp>
       <p:sp>
         <p:nvSpPr>
-          <p:cNvPr id="20" name="screen-P7"/>
+          <p:cNvPr id="22" name="screen-P8"/>
           <p:cNvSpPr/>
           <p:nvPr/>
         </p:nvSpPr>
         <p:spPr>
           <a:xfrm>
-            <a:off x="1828800" y="3063240"/>
+            <a:off x="3108960" y="3063240"/>
             <a:ext cx="1143000" cy="1188720"/>
           </a:xfrm>
           <a:prstGeom prst="roundRect">
@@ -9917,13 +10001,13 @@
       </p:sp>
       <p:sp>
         <p:nvSpPr>
-          <p:cNvPr id="21" name="Text 19"/>
+          <p:cNvPr id="23" name="Text 21"/>
           <p:cNvSpPr txBox="1"/>
           <p:nvPr/>
         </p:nvSpPr>
         <p:spPr>
           <a:xfrm>
-            <a:off x="1828800" y="3063240"/>
+            <a:off x="3108960" y="3063240"/>
             <a:ext cx="1143000" cy="1188720"/>
           </a:xfrm>
           <a:prstGeom prst="rect">
@@ -9945,7 +10029,7 @@
                   <a:schemeClr val="tx1"/>
                 </a:solidFill>
               </a:rPr>
-              <a:t>P7</a:t>
+              <a:t>P8</a:t>
             </a:r>
             <a:endParaRPr lang="en-US" sz="2200" dirty="0"/>
           </a:p>
@@ -9959,7 +10043,7 @@
                   <a:schemeClr val="tx1"/>
                 </a:solidFill>
               </a:rPr>
-              <a:t>Agenda</a:t>
+              <a:t>Detalle</a:t>
             </a:r>
             <a:endParaRPr lang="en-US" sz="2200" dirty="0"/>
           </a:p>
@@ -9967,13 +10051,13 @@
       </p:sp>
       <p:sp>
         <p:nvSpPr>
-          <p:cNvPr id="22" name="screen-P8"/>
+          <p:cNvPr id="24" name="screen-P9"/>
           <p:cNvSpPr/>
           <p:nvPr/>
         </p:nvSpPr>
         <p:spPr>
           <a:xfrm>
-            <a:off x="3108960" y="3063240"/>
+            <a:off x="4389120" y="3063240"/>
             <a:ext cx="1143000" cy="1188720"/>
           </a:xfrm>
           <a:prstGeom prst="roundRect">
@@ -9982,11 +10066,11 @@
             </a:avLst>
           </a:prstGeom>
           <a:solidFill>
-            <a:schemeClr val="bg2"/>
+            <a:schemeClr val="tx2"/>
           </a:solidFill>
           <a:ln w="12700">
             <a:solidFill>
-              <a:srgbClr val="E2E8F0"/>
+              <a:schemeClr val="tx2"/>
             </a:solidFill>
             <a:prstDash val="solid"/>
           </a:ln>
@@ -10001,13 +10085,13 @@
       </p:sp>
       <p:sp>
         <p:nvSpPr>
-          <p:cNvPr id="23" name="Text 21"/>
+          <p:cNvPr id="25" name="Text 23"/>
           <p:cNvSpPr txBox="1"/>
           <p:nvPr/>
         </p:nvSpPr>
         <p:spPr>
           <a:xfrm>
-            <a:off x="3108960" y="3063240"/>
+            <a:off x="4389120" y="3063240"/>
             <a:ext cx="1143000" cy="1188720"/>
           </a:xfrm>
           <a:prstGeom prst="rect">
@@ -10026,10 +10110,10 @@
             <a:r>
               <a:rPr lang="en-US" sz="2200" b="1" dirty="0">
                 <a:solidFill>
-                  <a:schemeClr val="tx1"/>
-                </a:solidFill>
-              </a:rPr>
-              <a:t>P8</a:t>
+                  <a:schemeClr val="bg1"/>
+                </a:solidFill>
+              </a:rPr>
+              <a:t>P9</a:t>
             </a:r>
             <a:endParaRPr lang="en-US" sz="2200" dirty="0"/>
           </a:p>
@@ -10040,91 +10124,7 @@
             <a:r>
               <a:rPr lang="en-US" sz="1100" dirty="0">
                 <a:solidFill>
-                  <a:schemeClr val="tx1"/>
-                </a:solidFill>
-              </a:rPr>
-              <a:t>Detalle</a:t>
-            </a:r>
-            <a:endParaRPr lang="en-US" sz="2200" dirty="0"/>
-          </a:p>
-        </p:txBody>
-      </p:sp>
-      <p:sp>
-        <p:nvSpPr>
-          <p:cNvPr id="24" name="screen-P9"/>
-          <p:cNvSpPr/>
-          <p:nvPr/>
-        </p:nvSpPr>
-        <p:spPr>
-          <a:xfrm>
-            <a:off x="4389120" y="3063240"/>
-            <a:ext cx="1143000" cy="1188720"/>
-          </a:xfrm>
-          <a:prstGeom prst="roundRect">
-            <a:avLst>
-              <a:gd name="adj" fmla="val 8000"/>
-            </a:avLst>
-          </a:prstGeom>
-          <a:solidFill>
-            <a:schemeClr val="bg2"/>
-          </a:solidFill>
-          <a:ln w="12700">
-            <a:solidFill>
-              <a:srgbClr val="E2E8F0"/>
-            </a:solidFill>
-            <a:prstDash val="solid"/>
-          </a:ln>
-        </p:spPr>
-        <p:txBody>
-          <a:bodyPr/>
-          <a:lstStyle/>
-          <a:p>
-            <a:endParaRPr lang="es-PE"/>
-          </a:p>
-        </p:txBody>
-      </p:sp>
-      <p:sp>
-        <p:nvSpPr>
-          <p:cNvPr id="25" name="Text 23"/>
-          <p:cNvSpPr txBox="1"/>
-          <p:nvPr/>
-        </p:nvSpPr>
-        <p:spPr>
-          <a:xfrm>
-            <a:off x="4389120" y="3063240"/>
-            <a:ext cx="1143000" cy="1188720"/>
-          </a:xfrm>
-          <a:prstGeom prst="rect">
-            <a:avLst/>
-          </a:prstGeom>
-          <a:noFill/>
-          <a:ln/>
-        </p:spPr>
-        <p:txBody>
-          <a:bodyPr wrap="square" lIns="0" tIns="0" rIns="0" bIns="0" rtlCol="0" anchor="ctr"/>
-          <a:lstStyle/>
-          <a:p>
-            <a:pPr marL="0" indent="0" algn="ctr">
-              <a:buNone/>
-            </a:pPr>
-            <a:r>
-              <a:rPr lang="en-US" sz="2200" b="1" dirty="0">
-                <a:solidFill>
-                  <a:schemeClr val="tx1"/>
-                </a:solidFill>
-              </a:rPr>
-              <a:t>P9</a:t>
-            </a:r>
-            <a:endParaRPr lang="en-US" sz="2200" dirty="0"/>
-          </a:p>
-          <a:p>
-            <a:pPr marL="0" indent="0" algn="ctr">
-              <a:buNone/>
-            </a:pPr>
-            <a:r>
-              <a:rPr lang="en-US" sz="1100" dirty="0">
-                <a:solidFill>
-                  <a:schemeClr val="tx1"/>
+                  <a:schemeClr val="bg1"/>
                 </a:solidFill>
               </a:rPr>
               <a:t>Rep. citas</a:t>
@@ -10944,7 +10944,7 @@
                   <a:srgbClr val="D1FAE5"/>
                 </a:solidFill>
               </a:rPr>
-              <a:t>Registro → Login → Reservar cita (apartado de 15 min)</a:t>
+              <a:t>Registro → Login → Reservar → Pago Yape → Confirmación</a:t>
             </a:r>
             <a:endParaRPr lang="en-US" sz="1600" dirty="0"/>
           </a:p>
@@ -11062,7 +11062,7 @@
                   <a:srgbClr val="D1FAE5"/>
                 </a:solidFill>
               </a:rPr>
-              <a:t>Login → Reporte de pagos → Exportar Excel</a:t>
+              <a:t>Login → Reportes de citas y pagos → Exportar Excel</a:t>
             </a:r>
             <a:endParaRPr lang="en-US" sz="1600" dirty="0"/>
           </a:p>
@@ -11290,7 +11290,7 @@
                   <a:schemeClr val="bg1"/>
                 </a:solidFill>
               </a:rPr>
-              <a:t>Implementar P3–P9 sobre los diseños aprobados</a:t>
+              <a:t>Implementar P5–P8 sobre los diseños aprobados</a:t>
             </a:r>
             <a:endParaRPr lang="en-US" sz="1500" dirty="0"/>
           </a:p>
@@ -13768,7 +13768,7 @@
                   <a:schemeClr val="accent6"/>
                 </a:solidFill>
               </a:rPr>
-              <a:t>AuthController · ReservaController · ReporteController</a:t>
+              <a:t>AuthController · ReservaController · PagoController · ReporteController</a:t>
             </a:r>
             <a:endParaRPr lang="en-US" sz="1600" dirty="0"/>
           </a:p>
@@ -13876,7 +13876,7 @@
                   <a:schemeClr val="accent6"/>
                 </a:solidFill>
               </a:rPr>
-              <a:t>PacienteService · ReservaService · ReporteService · MedicoService</a:t>
+              <a:t>PacienteService · ReservaService · PagoService · ReporteService · MedicoService</a:t>
             </a:r>
             <a:endParaRPr lang="en-US" sz="1600" dirty="0"/>
           </a:p>
@@ -14293,7 +14293,7 @@
                   <a:schemeClr val="accent6"/>
                 </a:solidFill>
               </a:rPr>
-              <a:t>, registro, reservar, reporte de pagos, errores 403/404.</a:t>
+              <a:t>, registro, reservar, pago, confirmación, reportes de citas y pagos, errores 403/404.</a:t>
             </a:r>
             <a:endParaRPr lang="en-US" sz="1400" dirty="0"/>
           </a:p>
@@ -15276,7 +15276,7 @@
                 <a:ea typeface="Courier New" pitchFamily="34" charset="-122"/>
                 <a:cs typeface="Courier New" pitchFamily="34" charset="-120"/>
               </a:rPr>
-              <a:t>service/ExportadorReporte · util/ExcelExportador</a:t>
+              <a:t>util/ExportadorReporte · util/ExcelExportador</a:t>
             </a:r>
             <a:endParaRPr lang="en-US" sz="1100" dirty="0"/>
           </a:p>
@@ -15445,7 +15445,7 @@
                   <a:schemeClr val="tx1"/>
                 </a:solidFill>
               </a:rPr>
-              <a:t>JUnit 5 + Mockito sobre reglas de negocio, controladores, seguridad y validaciones: 70 pruebas en 12 clases.</a:t>
+              <a:t>JUnit 5 + Mockito sobre reglas de negocio, controladores, seguridad y validaciones: 91 pruebas en 17 clases.</a:t>
             </a:r>
             <a:endParaRPr lang="en-US" sz="1400" dirty="0"/>
           </a:p>
@@ -15711,7 +15711,7 @@
                   <a:schemeClr val="tx2"/>
                 </a:solidFill>
               </a:rPr>
-              <a:t>79</a:t>
+              <a:t>98</a:t>
             </a:r>
             <a:endParaRPr lang="en-US" sz="4800" dirty="0"/>
           </a:p>
@@ -15824,7 +15824,7 @@
                   <a:schemeClr val="tx2"/>
                 </a:solidFill>
               </a:rPr>
-              <a:t>21</a:t>
+              <a:t>24</a:t>
             </a:r>
             <a:endParaRPr lang="en-US" sz="4800" dirty="0"/>
           </a:p>
@@ -15937,7 +15937,7 @@
                   <a:schemeClr val="tx2"/>
                 </a:solidFill>
               </a:rPr>
-              <a:t>17</a:t>
+              <a:t>23</a:t>
             </a:r>
             <a:endParaRPr lang="en-US" sz="4800" dirty="0"/>
           </a:p>
@@ -18880,7 +18880,7 @@
                             <a:schemeClr val="tx1"/>
                           </a:solidFill>
                         </a:rPr>
-                        <a:t>Exportar el reporte de pagos a .xlsx</a:t>
+                        <a:t>Exportar los reportes de citas y pagos a .xlsx</a:t>
                       </a:r>
                       <a:endParaRPr lang="en-US" sz="1400" dirty="0"/>
                     </a:p>
@@ -19306,7 +19306,7 @@
                             <a:schemeClr val="tx1"/>
                           </a:solidFill>
                         </a:rPr>
-                        <a:t>AlmacenamientoLocal</a:t>
+                        <a:t>PagoServiceImpl</a:t>
                       </a:r>
                       <a:endParaRPr lang="en-US" sz="1400" dirty="0"/>
                     </a:p>
@@ -19364,7 +19364,7 @@
                             <a:schemeClr val="tx1"/>
                           </a:solidFill>
                         </a:rPr>
-                        <a:t>Guardar constancias de pago de forma segura (P3)</a:t>
+                        <a:t>Guardar la constancia (P3); hoy se usa java.nio con nombre UUID</a:t>
                       </a:r>
                       <a:endParaRPr lang="en-US" sz="1400" dirty="0"/>
                     </a:p>
@@ -19606,7 +19606,7 @@
                             <a:schemeClr val="tx1"/>
                           </a:solidFill>
                         </a:rPr>
-                        <a:t>PDF de confirmación de la cita (P4)</a:t>
+                        <a:t>Descargar en PDF la confirmación (P4 ya funciona en pantalla)</a:t>
                       </a:r>
                       <a:endParaRPr lang="en-US" sz="1400" dirty="0"/>
                     </a:p>
@@ -19751,7 +19751,7 @@
                   <a:schemeClr val="accent6"/>
                 </a:solidFill>
               </a:rPr>
-              <a:t>Las dependencias pendientes ya están declaradas en pom.xml; su uso entra con las pantallas P3 y P4.</a:t>
+              <a:t>Commons IO y OpenPDF ya están en pom.xml: P3 y P4 funcionan, falta usarlas para la constancia y el PDF.</a:t>
             </a:r>
             <a:endParaRPr lang="en-US" sz="1300" dirty="0"/>
           </a:p>

</xml_diff>

<commit_message>
se agrega constancia y 10mil datos
</commit_message>
<xml_diff>
--- a/docs/entregables/MEDIFAST_APF3_Sustentacion.pptx
+++ b/docs/entregables/MEDIFAST_APF3_Sustentacion.pptx
@@ -315,13 +315,13 @@
                   <c:v>97</c:v>
                 </c:pt>
                 <c:pt idx="2">
-                  <c:v>77</c:v>
+                  <c:v>85</c:v>
                 </c:pt>
                 <c:pt idx="3">
-                  <c:v>58</c:v>
+                  <c:v>84</c:v>
                 </c:pt>
                 <c:pt idx="4">
-                  <c:v>73</c:v>
+                  <c:v>86</c:v>
                 </c:pt>
               </c:numCache>
             </c:numRef>
@@ -688,8 +688,8 @@
             <a:r>
               <a:rPr lang="en-US" dirty="0"/>
               <a:t>Expone: Jennifer.
-Tenemos 91 pruebas automatizadas en 17 clases, con JUnit 5 y Mockito, y todas pasan con ./mvnw test. Cubren las reglas de reserva —por ejemplo, que a un paciente nuevo solo se le ofrezcan inicios con dos bloques consecutivos libres, o que se rechacen fechas fuera de la ventana de 30 días—, el registro, la seguridad (bcrypt, bloqueo por intentos, redirección por rol), la generación de horarios, los reportes con su exportación a Excel y los controladores.
-JaCoCo reporta 73 % de cobertura total y 77 % en la capa de servicios, por encima de la meta del 60 % que nos pusimos. Le paso la palabra a Jack, que mostrará las interfaces.</a:t>
+Tenemos 168 pruebas automatizadas en 24 clases, con JUnit 5 y Mockito, y todas pasan con ./mvnw test. Cubren las reglas de reserva —por ejemplo, que a un paciente nuevo solo se le ofrezcan inicios con dos bloques consecutivos libres, o que se rechacen fechas fuera de la ventana de 30 días—, el registro, la seguridad (bcrypt, bloqueo por intentos, redirección por rol), la generación de horarios, los reportes con su exportación a Excel y los controladores.
+JaCoCo reporta 86 % de cobertura total y 85 % en la capa de servicios, por encima de la meta del 60 % que nos pusimos. Le paso la palabra a Jack, que mostrará las interfaces.</a:t>
             </a:r>
           </a:p>
         </p:txBody>
@@ -867,7 +867,7 @@
               <a:rPr lang="en-US" dirty="0"/>
               <a:t>Expone: Jack.
 El flujo del paciente tiene cuatro pasos. En P2 elige fecha y hora: el sistema ya detectó si es paciente nuevo o control, muestra solo los bloques libres y, al continuar, aparta el horario 15 minutos. En P3 ve el monto, un QR de ejemplo con la leyenda de simulación y un contador; adjunta su constancia. En P4 obtiene la confirmación con descarga en PDF, y en P5 consulta su historial.
-P2, P3 y P4 ya están implementadas en Spring Boot y conectadas a la base de datos; a la confirmación le falta la descarga en PDF. P5 está diseñada y es la siguiente en implementarse.</a:t>
+Las cuatro pantallas ya están implementadas en Spring Boot y conectadas a la base de datos. El PDF de confirmación se genera con OpenPDF y se descarga desde Mis citas, donde el paciente también puede ver su constancia.</a:t>
             </a:r>
           </a:p>
         </p:txBody>
@@ -956,7 +956,7 @@
               <a:rPr lang="en-US" dirty="0"/>
               <a:t>Expone: Jack.
 El médico entra directamente a su agenda (P7), con vista por día o semana, filtros por estado e indicadores. Desde ahí abre el detalle de una cita (P8): ve la constancia de pago y la valida o rechaza; rechazar o cancelar exige una observación, y solo puede marcar atendida si el pago está validado.
-Tiene dos reportes, y ambos ya están implementados. El de citas (P9) filtra por día, semana y estado y muestra total, atendidas, canceladas y no asistieron. El de pagos (P10) filtra por período y muestra cantidad, total y ticket promedio. Los dos exportan a Excel con Apache POI. La agenda y el detalle de cita están diseñados y en desarrollo.</a:t>
+Tiene dos reportes, y ambos ya están implementados. El de citas (P9) filtra por día, semana y estado y muestra total, atendidas, canceladas y no asistieron. El de pagos (P10) filtra por período y muestra cantidad, total y ticket promedio. Los dos exportan a Excel con Apache POI. La agenda (P7) también ya está implementada, con vista por día o semana, filtro por estado e indicadores. El detalle de cita (P8), donde se valida o rechaza el pago, está diseñado y es la pantalla que falta.</a:t>
             </a:r>
           </a:p>
         </p:txBody>
@@ -1044,7 +1044,7 @@
             <a:r>
               <a:rPr lang="en-US" dirty="0"/>
               <a:t>Expone: Jack.
-Con transparencia, este es el estado frente al alcance comprometido. Las 11 pantallas tienen su diseño aprobado. En código, ya funcionan con su lógica y base de datos siete: el login, el registro, la reserva de citas, el pago simulado, la confirmación y los dos reportes con exportación a Excel, además de las páginas de error 403 y 404. Las cuatro restantes —mis citas, mi perfil, la agenda y el detalle de cita— están en implementación para completar el 100 % del alcance.
+Con transparencia, este es el estado frente al alcance comprometido. Las 11 pantallas tienen su diseño aprobado. En código, ya funcionan con su lógica y base de datos diez de las once: login, registro, reserva, pago simulado, confirmación, mis citas, mi perfil, agenda y los dos reportes con exportación a Excel, además de las páginas de error 403 y 404. Solo falta el detalle de cita (P8), donde el médico valida o rechaza el pago y marca atendida o no asistió, para completar el 100 % del alcance.
 Lo que sí garantizamos es la coherencia: el README es la referencia única, y el código, los scripts SQL, los diagramas y los diseños usan los mismos identificadores de pantallas, requerimientos y reglas.</a:t>
             </a:r>
           </a:p>
@@ -1133,8 +1133,8 @@
             <a:r>
               <a:rPr lang="en-US" dirty="0"/>
               <a:t>Expone: Jack (con apoyo de todo el equipo en la demo).
-Ahora lo vemos funcionando en localhost. Primero el flujo del paciente: registro, inicio de sesión, reserva de una cita —el horario queda apartado 15 minutos—, pago simulado con Yape adjuntando la constancia y la confirmación. Luego el médico: inicio de sesión, reportes de citas y de pagos, y exportación a Excel. Por último, la seguridad: un paciente que intenta entrar a una ruta de médico recibe 403, y tras cinco intentos fallidos la cuenta se bloquea.
-Para la entrega final implementaremos las pantallas P5 a P8 sobre los diseños ya aprobados, incorporaremos Commons IO y OpenPDF, completaremos las pruebas de las 14 reglas de negocio y validaremos el sistema con el Dr. Barrantes. Muchas gracias; quedamos atentos a sus preguntas.</a:t>
+Ahora lo vemos funcionando en localhost. Primero el flujo del paciente: reserva de una cita —el horario queda apartado 15 minutos—, pago simulado con Yape adjuntando la constancia, la confirmación y Mis citas, desde donde descarga el PDF. Luego el médico: inicio de sesión, su agenda, los reportes de citas y de pagos, y la exportación a Excel. Por último, la seguridad: un paciente que intenta entrar a una ruta de médico recibe 403, y tras cinco intentos fallidos la cuenta se bloquea.
+Para la entrega final implementaremos el detalle de cita (P8) sobre su diseño ya aprobado, documentaremos los servicios con Javadoc, completaremos las pruebas de las 14 reglas de negocio y validaremos el sistema con el Dr. Barrantes. Muchas gracias; quedamos atentos a sus preguntas.</a:t>
             </a:r>
           </a:p>
         </p:txBody>
@@ -1580,7 +1580,7 @@
               <a:rPr lang="en-US" dirty="0"/>
               <a:t>Expone: Manuel.
 La rúbrica pide al menos tres de estos principios; aplicamos los cuatro.
-MVC: modelo con entidades y DTO, vistas Thymeleaf y controladores delgados. DAO: cada tabla tiene su interfaz que extiende JpaRepository, con consultas propias para disponibilidad y reportes. SOLID: por ejemplo, ExportadorReporte es una interfaz; el controlador de reportes depende de ella y no de Apache POI, así que agregar un exportador a PDF no obliga a tocar el servicio —principios abierto/cerrado e inversión de dependencias—. TDD: 91 pruebas con JUnit 5 y Mockito, que veremos más adelante.</a:t>
+MVC: modelo con entidades y DTO, vistas Thymeleaf y controladores delgados. DAO: cada tabla tiene su interfaz que extiende JpaRepository, con consultas propias para disponibilidad y reportes. SOLID: por ejemplo, ExportadorReporte es una interfaz; el controlador de reportes depende de ella y no de Apache POI, así que agregar un exportador a PDF no obliga a tocar el servicio —principios abierto/cerrado e inversión de dependencias—. TDD: 168 pruebas con JUnit 5 y Mockito, que veremos más adelante.</a:t>
             </a:r>
           </a:p>
         </p:txBody>
@@ -1668,7 +1668,7 @@
             <a:r>
               <a:rPr lang="en-US" dirty="0"/>
               <a:t>Expone: Manuel.
-Todo el proyecto está en GitHub: 98 commits en main y 24 pull requests, de los cuales 23 ya están integrados. El flujo es siempre el mismo: una rama feature por funcionalidad o pantalla, commits pequeños, un pull request que revisa el equipo y la integración a main.
+Todo el proyecto está en GitHub: 106 commits en main y 28 pull requests, de los cuales 27 ya están integrados. El flujo es siempre el mismo: una rama feature por funcionalidad o pantalla, commits pequeños, un pull request que revisa el equipo y la integración a main.
 No solo versionamos código: también los scripts SQL, los diagramas en Mermaid, la bitácora de diseño con cada prompt y captura, y los entregables anteriores. El README es la fuente única de verdad: si un documento lo contradice, se corrige el documento. Ahora Jennifer presentará seguridad, librerías y pruebas.</a:t>
             </a:r>
           </a:p>
@@ -1847,7 +1847,7 @@
               <a:rPr lang="en-US" dirty="0"/>
               <a:t>Expone: Jennifer.
 No basta con declarar las librerías en el pom.xml: cada una debe tener un uso real. Google Guava se usa para la caché de intentos de login. Apache Commons Lang3, con StringUtils, normaliza nombres y documentos en el registro, el enmascarador y la auditoría. Apache POI genera el Excel de los reportes de citas y de pagos. Logback está configurado con consola, archivo rotativo y un log de auditoría separado, y enmascara los datos sensibles.
-Con honestidad: Commons IO y OpenPDF ya están en el pom.xml, pero todavía no se usan. Las pantallas de pago y de confirmación ya funcionan: hoy la constancia se guarda con java.nio y un nombre UUID, y la descarga en PDF de la confirmación es lo siguiente que implementaremos.</a:t>
+Además, Apache Commons IO se usa en ConstanciaServiceImpl: con FilenameUtils se entrega la constancia de pago con un nombre seguro, y solo al paciente dueño de la cita. OpenPDF genera el PDF de confirmación de la cita, que el paciente descarga desde Mis citas. Así, las seis librerías del pom.xml tienen un uso real en el código.</a:t>
             </a:r>
           </a:p>
         </p:txBody>
@@ -3134,7 +3134,7 @@
                   <a:schemeClr val="tx1"/>
                 </a:solidFill>
               </a:rPr>
-              <a:t>91 pruebas automatizadas en verde</a:t>
+              <a:t>168 pruebas automatizadas en verde</a:t>
             </a:r>
             <a:endParaRPr lang="en-US" sz="3600" dirty="0"/>
           </a:p>
@@ -3211,7 +3211,7 @@
                   <a:schemeClr val="tx2"/>
                 </a:solidFill>
               </a:rPr>
-              <a:t>91</a:t>
+              <a:t>168</a:t>
             </a:r>
             <a:endParaRPr lang="en-US" sz="4400" dirty="0"/>
           </a:p>
@@ -3338,7 +3338,7 @@
                   <a:schemeClr val="tx2"/>
                 </a:solidFill>
               </a:rPr>
-              <a:t>73 %</a:t>
+              <a:t>86 %</a:t>
             </a:r>
             <a:endParaRPr lang="en-US" sz="4400" dirty="0"/>
           </a:p>
@@ -3465,7 +3465,7 @@
                   <a:schemeClr val="tx2"/>
                 </a:solidFill>
               </a:rPr>
-              <a:t>77 %</a:t>
+              <a:t>85 %</a:t>
             </a:r>
             <a:endParaRPr lang="en-US" sz="4400" dirty="0"/>
           </a:p>
@@ -6872,7 +6872,7 @@
             <a:avLst/>
           </a:prstGeom>
           <a:solidFill>
-            <a:srgbClr val="FEF3C7"/>
+            <a:srgbClr val="D1FAE5"/>
           </a:solidFill>
           <a:ln/>
         </p:spPr>
@@ -6886,10 +6886,10 @@
             <a:r>
               <a:rPr lang="en-US" sz="1000" b="1" dirty="0">
                 <a:solidFill>
-                  <a:srgbClr val="92400E"/>
-                </a:solidFill>
-              </a:rPr>
-              <a:t>Diseñada</a:t>
+                  <a:schemeClr val="tx2"/>
+                </a:solidFill>
+              </a:rPr>
+              <a:t>Implementada</a:t>
             </a:r>
             <a:endParaRPr lang="en-US" sz="1000" dirty="0"/>
           </a:p>
@@ -9730,11 +9730,11 @@
             </a:avLst>
           </a:prstGeom>
           <a:solidFill>
-            <a:schemeClr val="bg2"/>
+            <a:schemeClr val="tx2"/>
           </a:solidFill>
           <a:ln w="12700">
             <a:solidFill>
-              <a:srgbClr val="E2E8F0"/>
+              <a:schemeClr val="tx2"/>
             </a:solidFill>
             <a:prstDash val="solid"/>
           </a:ln>
@@ -9774,7 +9774,7 @@
             <a:r>
               <a:rPr lang="en-US" sz="2200" b="1" dirty="0">
                 <a:solidFill>
-                  <a:schemeClr val="tx1"/>
+                  <a:schemeClr val="bg1"/>
                 </a:solidFill>
               </a:rPr>
               <a:t>P5</a:t>
@@ -9788,7 +9788,7 @@
             <a:r>
               <a:rPr lang="en-US" sz="1100" dirty="0">
                 <a:solidFill>
-                  <a:schemeClr val="tx1"/>
+                  <a:schemeClr val="bg1"/>
                 </a:solidFill>
               </a:rPr>
               <a:t>Mis citas</a:t>
@@ -9814,11 +9814,11 @@
             </a:avLst>
           </a:prstGeom>
           <a:solidFill>
-            <a:schemeClr val="bg2"/>
+            <a:schemeClr val="tx2"/>
           </a:solidFill>
           <a:ln w="12700">
             <a:solidFill>
-              <a:srgbClr val="E2E8F0"/>
+              <a:schemeClr val="tx2"/>
             </a:solidFill>
             <a:prstDash val="solid"/>
           </a:ln>
@@ -9858,7 +9858,7 @@
             <a:r>
               <a:rPr lang="en-US" sz="2200" b="1" dirty="0">
                 <a:solidFill>
-                  <a:schemeClr val="tx1"/>
+                  <a:schemeClr val="bg1"/>
                 </a:solidFill>
               </a:rPr>
               <a:t>P6</a:t>
@@ -9872,7 +9872,7 @@
             <a:r>
               <a:rPr lang="en-US" sz="1100" dirty="0">
                 <a:solidFill>
-                  <a:schemeClr val="tx1"/>
+                  <a:schemeClr val="bg1"/>
                 </a:solidFill>
               </a:rPr>
               <a:t>Mi perfil</a:t>
@@ -9898,11 +9898,11 @@
             </a:avLst>
           </a:prstGeom>
           <a:solidFill>
-            <a:schemeClr val="bg2"/>
+            <a:schemeClr val="tx2"/>
           </a:solidFill>
           <a:ln w="12700">
             <a:solidFill>
-              <a:srgbClr val="E2E8F0"/>
+              <a:schemeClr val="tx2"/>
             </a:solidFill>
             <a:prstDash val="solid"/>
           </a:ln>
@@ -9942,7 +9942,7 @@
             <a:r>
               <a:rPr lang="en-US" sz="2200" b="1" dirty="0">
                 <a:solidFill>
-                  <a:schemeClr val="tx1"/>
+                  <a:schemeClr val="bg1"/>
                 </a:solidFill>
               </a:rPr>
               <a:t>P7</a:t>
@@ -9956,7 +9956,7 @@
             <a:r>
               <a:rPr lang="en-US" sz="1100" dirty="0">
                 <a:solidFill>
-                  <a:schemeClr val="tx1"/>
+                  <a:schemeClr val="bg1"/>
                 </a:solidFill>
               </a:rPr>
               <a:t>Agenda</a:t>
@@ -10944,7 +10944,7 @@
                   <a:srgbClr val="D1FAE5"/>
                 </a:solidFill>
               </a:rPr>
-              <a:t>Registro → Login → Reservar → Pago Yape → Confirmación</a:t>
+              <a:t>Reservar → Pago Yape → Confirmación → Mis citas (PDF)</a:t>
             </a:r>
             <a:endParaRPr lang="en-US" sz="1600" dirty="0"/>
           </a:p>
@@ -11062,7 +11062,7 @@
                   <a:srgbClr val="D1FAE5"/>
                 </a:solidFill>
               </a:rPr>
-              <a:t>Login → Reportes de citas y pagos → Exportar Excel</a:t>
+              <a:t>Login → Agenda → Reportes de citas y pagos → Excel</a:t>
             </a:r>
             <a:endParaRPr lang="en-US" sz="1600" dirty="0"/>
           </a:p>
@@ -11290,7 +11290,7 @@
                   <a:schemeClr val="bg1"/>
                 </a:solidFill>
               </a:rPr>
-              <a:t>Implementar P5–P8 sobre los diseños aprobados</a:t>
+              <a:t>Implementar P8: validar pagos y cerrar la cita</a:t>
             </a:r>
             <a:endParaRPr lang="en-US" sz="1500" dirty="0"/>
           </a:p>
@@ -11308,7 +11308,7 @@
                   <a:schemeClr val="bg1"/>
                 </a:solidFill>
               </a:rPr>
-              <a:t>Commons IO para constancias y OpenPDF para la confirmación</a:t>
+              <a:t>Javadoc de los servicios y capturas de P0–P10</a:t>
             </a:r>
             <a:endParaRPr lang="en-US" sz="1500" dirty="0"/>
           </a:p>
@@ -13768,7 +13768,7 @@
                   <a:schemeClr val="accent6"/>
                 </a:solidFill>
               </a:rPr>
-              <a:t>AuthController · ReservaController · PagoController · ReporteController</a:t>
+              <a:t>7 controladores: Auth, Reserva, Pago, MisCitas, Perfil, Agenda, Reporte</a:t>
             </a:r>
             <a:endParaRPr lang="en-US" sz="1600" dirty="0"/>
           </a:p>
@@ -13876,7 +13876,7 @@
                   <a:schemeClr val="accent6"/>
                 </a:solidFill>
               </a:rPr>
-              <a:t>PacienteService · ReservaService · PagoService · ReporteService · MedicoService</a:t>
+              <a:t>9 servicios: Reserva, Pago, GestionCita, Reporte, ConfirmacionPdf, Constancia…</a:t>
             </a:r>
             <a:endParaRPr lang="en-US" sz="1600" dirty="0"/>
           </a:p>
@@ -14293,7 +14293,7 @@
                   <a:schemeClr val="accent6"/>
                 </a:solidFill>
               </a:rPr>
-              <a:t>, registro, reservar, pago, confirmación, reportes de citas y pagos, errores 403/404.</a:t>
+              <a:t>, registro, reservar, pago, confirmación, mis citas, perfil, agenda, reportes y errores 403/404.</a:t>
             </a:r>
             <a:endParaRPr lang="en-US" sz="1400" dirty="0"/>
           </a:p>
@@ -15445,7 +15445,7 @@
                   <a:schemeClr val="tx1"/>
                 </a:solidFill>
               </a:rPr>
-              <a:t>JUnit 5 + Mockito sobre reglas de negocio, controladores, seguridad y validaciones: 91 pruebas en 17 clases.</a:t>
+              <a:t>JUnit 5 + Mockito sobre reglas de negocio, controladores, seguridad y validaciones: 168 pruebas en 24 clases.</a:t>
             </a:r>
             <a:endParaRPr lang="en-US" sz="1400" dirty="0"/>
           </a:p>
@@ -15711,7 +15711,7 @@
                   <a:schemeClr val="tx2"/>
                 </a:solidFill>
               </a:rPr>
-              <a:t>98</a:t>
+              <a:t>106</a:t>
             </a:r>
             <a:endParaRPr lang="en-US" sz="4800" dirty="0"/>
           </a:p>
@@ -15824,7 +15824,7 @@
                   <a:schemeClr val="tx2"/>
                 </a:solidFill>
               </a:rPr>
-              <a:t>24</a:t>
+              <a:t>28</a:t>
             </a:r>
             <a:endParaRPr lang="en-US" sz="4800" dirty="0"/>
           </a:p>
@@ -15937,7 +15937,7 @@
                   <a:schemeClr val="tx2"/>
                 </a:solidFill>
               </a:rPr>
-              <a:t>23</a:t>
+              <a:t>27</a:t>
             </a:r>
             <a:endParaRPr lang="en-US" sz="4800" dirty="0"/>
           </a:p>
@@ -19306,7 +19306,7 @@
                             <a:schemeClr val="tx1"/>
                           </a:solidFill>
                         </a:rPr>
-                        <a:t>PagoServiceImpl</a:t>
+                        <a:t>ConstanciaServiceImpl</a:t>
                       </a:r>
                       <a:endParaRPr lang="en-US" sz="1400" dirty="0"/>
                     </a:p>
@@ -19364,7 +19364,7 @@
                             <a:schemeClr val="tx1"/>
                           </a:solidFill>
                         </a:rPr>
-                        <a:t>Guardar la constancia (P3); hoy se usa java.nio con nombre UUID</a:t>
+                        <a:t>FilenameUtils para entregar la constancia con un nombre seguro</a:t>
                       </a:r>
                       <a:endParaRPr lang="en-US" sz="1400" dirty="0"/>
                     </a:p>
@@ -19419,10 +19419,10 @@
                       <a:r>
                         <a:rPr lang="en-US" sz="1400" b="1" dirty="0">
                           <a:solidFill>
-                            <a:srgbClr val="92400E"/>
+                            <a:schemeClr val="tx2"/>
                           </a:solidFill>
                         </a:rPr>
-                        <a:t>Pendiente</a:t>
+                        <a:t>En uso</a:t>
                       </a:r>
                       <a:endParaRPr lang="en-US" sz="1400" dirty="0"/>
                     </a:p>
@@ -19465,7 +19465,7 @@
                       <a:tailEnd type="none" w="med" len="med"/>
                     </a:lnB>
                     <a:solidFill>
-                      <a:srgbClr val="FEF3C7"/>
+                      <a:srgbClr val="D1FAE5"/>
                     </a:solidFill>
                   </a:tcPr>
                 </a:tc>
@@ -19548,7 +19548,7 @@
                             <a:schemeClr val="tx1"/>
                           </a:solidFill>
                         </a:rPr>
-                        <a:t>ConfirmacionPdfService</a:t>
+                        <a:t>ConfirmacionPdfServiceImpl</a:t>
                       </a:r>
                       <a:endParaRPr lang="en-US" sz="1400" dirty="0"/>
                     </a:p>
@@ -19606,7 +19606,7 @@
                             <a:schemeClr val="tx1"/>
                           </a:solidFill>
                         </a:rPr>
-                        <a:t>Descargar en PDF la confirmación (P4 ya funciona en pantalla)</a:t>
+                        <a:t>PDF de confirmación de la cita, descargable desde Mis citas</a:t>
                       </a:r>
                       <a:endParaRPr lang="en-US" sz="1400" dirty="0"/>
                     </a:p>
@@ -19661,10 +19661,10 @@
                       <a:r>
                         <a:rPr lang="en-US" sz="1400" b="1" dirty="0">
                           <a:solidFill>
-                            <a:srgbClr val="92400E"/>
+                            <a:schemeClr val="tx2"/>
                           </a:solidFill>
                         </a:rPr>
-                        <a:t>Pendiente</a:t>
+                        <a:t>En uso</a:t>
                       </a:r>
                       <a:endParaRPr lang="en-US" sz="1400" dirty="0"/>
                     </a:p>
@@ -19707,7 +19707,7 @@
                       <a:tailEnd type="none" w="med" len="med"/>
                     </a:lnB>
                     <a:solidFill>
-                      <a:srgbClr val="FEF3C7"/>
+                      <a:srgbClr val="D1FAE5"/>
                     </a:solidFill>
                   </a:tcPr>
                 </a:tc>
@@ -19751,7 +19751,7 @@
                   <a:schemeClr val="accent6"/>
                 </a:solidFill>
               </a:rPr>
-              <a:t>Commons IO y OpenPDF ya están en pom.xml: P3 y P4 funcionan, falta usarlas para la constancia y el PDF.</a:t>
+              <a:t>Las seis librerías declaradas en pom.xml tienen un uso verificable en el código.</a:t>
             </a:r>
             <a:endParaRPr lang="en-US" sz="1300" dirty="0"/>
           </a:p>

</xml_diff>